<commit_message>
Update 139788 Step 3 Dead-leg and Hold-up Retrofit_EN_1page.pptx
</commit_message>
<xml_diff>
--- a/139788 Step 3 Dead-leg and Hold-up Retrofit_EN_1page.pptx
+++ b/139788 Step 3 Dead-leg and Hold-up Retrofit_EN_1page.pptx
@@ -3258,7 +3258,7 @@
           <p:nvPr/>
         </p:nvGraphicFramePr>
         <p:xfrm>
-          <a:off x="292608" y="804672"/>
+          <a:off x="292608" y="713232"/>
           <a:ext cx="11612880" cy="4114800"/>
         </p:xfrm>
         <a:graphic>
@@ -3514,7 +3514,10 @@
                     <a:bodyPr wrap="square"/>
                     <a:lstStyle/>
                     <a:p>
-                      <a:pPr algn="l"/>
+                      <a:pPr marL="342900" indent="-342900" algn="l">
+                        <a:buFont typeface="+mj-lt"/>
+                        <a:buAutoNum type="arabicPeriod"/>
+                      </a:pPr>
                       <a:r>
                         <a:rPr sz="1300" b="0">
                           <a:solidFill>
@@ -3524,7 +3527,79 @@
                           <a:ea typeface="DejaVu Sans"/>
                           <a:cs typeface="Calibri" panose="020F0502020204030204" charset="0"/>
                         </a:rPr>
-                        <a:t>Dead legs outside the 2D/3D criterion, diaphragm valves that are not self-draining, and non-BPE piping stay in place.</a:t>
+                        <a:t>Dead legs outside the 2D/3D criterion, </a:t>
+                      </a:r>
+                      <a:endParaRPr sz="1300" b="0">
+                        <a:solidFill>
+                          <a:srgbClr val="1C2833"/>
+                        </a:solidFill>
+                        <a:latin typeface="Calibri" panose="020F0502020204030204" charset="0"/>
+                        <a:ea typeface="DejaVu Sans"/>
+                        <a:cs typeface="Calibri" panose="020F0502020204030204" charset="0"/>
+                      </a:endParaRPr>
+                    </a:p>
+                    <a:p>
+                      <a:pPr marL="342900" indent="-342900" algn="l">
+                        <a:buFont typeface="+mj-lt"/>
+                        <a:buAutoNum type="arabicPeriod"/>
+                      </a:pPr>
+                      <a:r>
+                        <a:rPr lang="en-US" sz="1300" b="0">
+                          <a:solidFill>
+                            <a:srgbClr val="1C2833"/>
+                          </a:solidFill>
+                          <a:latin typeface="Calibri" panose="020F0502020204030204" charset="0"/>
+                          <a:ea typeface="DejaVu Sans"/>
+                          <a:cs typeface="Calibri" panose="020F0502020204030204" charset="0"/>
+                        </a:rPr>
+                        <a:t>D</a:t>
+                      </a:r>
+                      <a:r>
+                        <a:rPr sz="1300" b="0">
+                          <a:solidFill>
+                            <a:srgbClr val="1C2833"/>
+                          </a:solidFill>
+                          <a:latin typeface="Calibri" panose="020F0502020204030204" charset="0"/>
+                          <a:ea typeface="DejaVu Sans"/>
+                          <a:cs typeface="Calibri" panose="020F0502020204030204" charset="0"/>
+                        </a:rPr>
+                        <a:t>iaphragm valves that are not self-draining, </a:t>
+                      </a:r>
+                      <a:endParaRPr sz="1300" b="0">
+                        <a:solidFill>
+                          <a:srgbClr val="1C2833"/>
+                        </a:solidFill>
+                        <a:latin typeface="Calibri" panose="020F0502020204030204" charset="0"/>
+                        <a:ea typeface="DejaVu Sans"/>
+                        <a:cs typeface="Calibri" panose="020F0502020204030204" charset="0"/>
+                      </a:endParaRPr>
+                    </a:p>
+                    <a:p>
+                      <a:pPr marL="342900" indent="-342900" algn="l">
+                        <a:buFont typeface="+mj-lt"/>
+                        <a:buAutoNum type="arabicPeriod"/>
+                      </a:pPr>
+                      <a:r>
+                        <a:rPr lang="en-US" sz="1300" b="0">
+                          <a:solidFill>
+                            <a:srgbClr val="1C2833"/>
+                          </a:solidFill>
+                          <a:latin typeface="Calibri" panose="020F0502020204030204" charset="0"/>
+                          <a:ea typeface="DejaVu Sans"/>
+                          <a:cs typeface="Calibri" panose="020F0502020204030204" charset="0"/>
+                        </a:rPr>
+                        <a:t>N</a:t>
+                      </a:r>
+                      <a:r>
+                        <a:rPr sz="1300" b="0">
+                          <a:solidFill>
+                            <a:srgbClr val="1C2833"/>
+                          </a:solidFill>
+                          <a:latin typeface="Calibri" panose="020F0502020204030204" charset="0"/>
+                          <a:ea typeface="DejaVu Sans"/>
+                          <a:cs typeface="Calibri" panose="020F0502020204030204" charset="0"/>
+                        </a:rPr>
+                        <a:t>on-BPE piping stay in place.</a:t>
                       </a:r>
                       <a:endParaRPr sz="1300" b="0">
                         <a:solidFill>
@@ -3547,7 +3622,9 @@
                     <a:bodyPr wrap="square"/>
                     <a:lstStyle/>
                     <a:p>
-                      <a:pPr algn="l"/>
+                      <a:pPr marL="342900" indent="-342900" algn="l">
+                        <a:buAutoNum type="arabicPeriod"/>
+                      </a:pPr>
                       <a:r>
                         <a:rPr sz="1300" b="0">
                           <a:solidFill>
@@ -3557,7 +3634,31 @@
                           <a:ea typeface="DejaVu Sans"/>
                           <a:cs typeface="Calibri" panose="020F0502020204030204" charset="0"/>
                         </a:rPr>
-                        <a:t>Hold-up can degrade material, support microbial growth, or cause cross-contamination. Flush, drain, purge, and disassembly after each use are not defined.</a:t>
+                        <a:t>Hold-up can degrade material, support microbial growth, or cause cross-contamination. </a:t>
+                      </a:r>
+                      <a:endParaRPr sz="1300" b="0">
+                        <a:solidFill>
+                          <a:srgbClr val="1C2833"/>
+                        </a:solidFill>
+                        <a:latin typeface="Calibri" panose="020F0502020204030204" charset="0"/>
+                        <a:ea typeface="DejaVu Sans"/>
+                        <a:cs typeface="Calibri" panose="020F0502020204030204" charset="0"/>
+                      </a:endParaRPr>
+                    </a:p>
+                    <a:p>
+                      <a:pPr marL="342900" indent="-342900" algn="l">
+                        <a:buAutoNum type="arabicPeriod"/>
+                      </a:pPr>
+                      <a:r>
+                        <a:rPr sz="1300" b="0">
+                          <a:solidFill>
+                            <a:srgbClr val="1C2833"/>
+                          </a:solidFill>
+                          <a:latin typeface="Calibri" panose="020F0502020204030204" charset="0"/>
+                          <a:ea typeface="DejaVu Sans"/>
+                          <a:cs typeface="Calibri" panose="020F0502020204030204" charset="0"/>
+                        </a:rPr>
+                        <a:t>Flush, drain, purge, and disassembly after each use are not defined.</a:t>
                       </a:r>
                       <a:endParaRPr sz="1300" b="0">
                         <a:solidFill>
@@ -3580,7 +3681,9 @@
                     <a:bodyPr wrap="square"/>
                     <a:lstStyle/>
                     <a:p>
-                      <a:pPr algn="l"/>
+                      <a:pPr marL="342900" indent="-342900" algn="l">
+                        <a:buAutoNum type="arabicPeriod"/>
+                      </a:pPr>
                       <a:r>
                         <a:rPr sz="1300" b="0">
                           <a:solidFill>
@@ -3590,7 +3693,31 @@
                           <a:ea typeface="DejaVu Sans"/>
                           <a:cs typeface="Calibri" panose="020F0502020204030204" charset="0"/>
                         </a:rPr>
-                        <a:t>After each system transfer, flush or clean with process solvent, supported by bioburden data. Define those steps in the procedures.</a:t>
+                        <a:t>After each system transfer, flush or clean with process solvent, supported by bioburden data. </a:t>
+                      </a:r>
+                      <a:endParaRPr sz="1300" b="0">
+                        <a:solidFill>
+                          <a:srgbClr val="1C2833"/>
+                        </a:solidFill>
+                        <a:latin typeface="Calibri" panose="020F0502020204030204" charset="0"/>
+                        <a:ea typeface="DejaVu Sans"/>
+                        <a:cs typeface="Calibri" panose="020F0502020204030204" charset="0"/>
+                      </a:endParaRPr>
+                    </a:p>
+                    <a:p>
+                      <a:pPr marL="342900" indent="-342900" algn="l">
+                        <a:buAutoNum type="arabicPeriod"/>
+                      </a:pPr>
+                      <a:r>
+                        <a:rPr sz="1300" b="0">
+                          <a:solidFill>
+                            <a:srgbClr val="1C2833"/>
+                          </a:solidFill>
+                          <a:latin typeface="Calibri" panose="020F0502020204030204" charset="0"/>
+                          <a:ea typeface="DejaVu Sans"/>
+                          <a:cs typeface="Calibri" panose="020F0502020204030204" charset="0"/>
+                        </a:rPr>
+                        <a:t>Define those steps in the procedures.</a:t>
                       </a:r>
                       <a:endParaRPr sz="1300" b="0">
                         <a:solidFill>
@@ -3747,7 +3874,9 @@
                     <a:bodyPr wrap="square"/>
                     <a:lstStyle/>
                     <a:p>
-                      <a:pPr algn="l"/>
+                      <a:pPr marL="342900" indent="-342900" algn="l">
+                        <a:buAutoNum type="arabicPeriod"/>
+                      </a:pPr>
                       <a:r>
                         <a:rPr sz="1300" b="0">
                           <a:solidFill>
@@ -3757,7 +3886,31 @@
                           <a:ea typeface="DejaVu Sans"/>
                           <a:cs typeface="Calibri" panose="020F0502020204030204" charset="0"/>
                         </a:rPr>
-                        <a:t>New change control, with a concern for product quality. The risk assessment of pre-use and post-use operations is not yet sufficient.</a:t>
+                        <a:t>New change control, with a concern for product quality. </a:t>
+                      </a:r>
+                      <a:endParaRPr sz="1300" b="0">
+                        <a:solidFill>
+                          <a:srgbClr val="1C2833"/>
+                        </a:solidFill>
+                        <a:latin typeface="Calibri" panose="020F0502020204030204" charset="0"/>
+                        <a:ea typeface="DejaVu Sans"/>
+                        <a:cs typeface="Calibri" panose="020F0502020204030204" charset="0"/>
+                      </a:endParaRPr>
+                    </a:p>
+                    <a:p>
+                      <a:pPr marL="342900" indent="-342900" algn="l">
+                        <a:buAutoNum type="arabicPeriod"/>
+                      </a:pPr>
+                      <a:r>
+                        <a:rPr sz="1300" b="0">
+                          <a:solidFill>
+                            <a:srgbClr val="1C2833"/>
+                          </a:solidFill>
+                          <a:latin typeface="Calibri" panose="020F0502020204030204" charset="0"/>
+                          <a:ea typeface="DejaVu Sans"/>
+                          <a:cs typeface="Calibri" panose="020F0502020204030204" charset="0"/>
+                        </a:rPr>
+                        <a:t>The risk assessment of pre-use and post-use operations is not yet sufficient.</a:t>
                       </a:r>
                       <a:endParaRPr sz="1300" b="0">
                         <a:solidFill>
@@ -3780,7 +3933,9 @@
                     <a:bodyPr wrap="square"/>
                     <a:lstStyle/>
                     <a:p>
-                      <a:pPr algn="l"/>
+                      <a:pPr marL="342900" indent="-342900" algn="l">
+                        <a:buAutoNum type="arabicPeriod"/>
+                      </a:pPr>
                       <a:r>
                         <a:rPr sz="1300" b="0">
                           <a:solidFill>
@@ -3790,7 +3945,31 @@
                           <a:ea typeface="DejaVu Sans"/>
                           <a:cs typeface="Calibri" panose="020F0502020204030204" charset="0"/>
                         </a:rPr>
-                        <a:t>Qualify the modified piping. Define the operating and cleaning sequence and update the records.</a:t>
+                        <a:t>Qualify the modified piping. </a:t>
+                      </a:r>
+                      <a:endParaRPr sz="1300" b="0">
+                        <a:solidFill>
+                          <a:srgbClr val="1C2833"/>
+                        </a:solidFill>
+                        <a:latin typeface="Calibri" panose="020F0502020204030204" charset="0"/>
+                        <a:ea typeface="DejaVu Sans"/>
+                        <a:cs typeface="Calibri" panose="020F0502020204030204" charset="0"/>
+                      </a:endParaRPr>
+                    </a:p>
+                    <a:p>
+                      <a:pPr marL="342900" indent="-342900" algn="l">
+                        <a:buAutoNum type="arabicPeriod"/>
+                      </a:pPr>
+                      <a:r>
+                        <a:rPr sz="1300" b="0">
+                          <a:solidFill>
+                            <a:srgbClr val="1C2833"/>
+                          </a:solidFill>
+                          <a:latin typeface="Calibri" panose="020F0502020204030204" charset="0"/>
+                          <a:ea typeface="DejaVu Sans"/>
+                          <a:cs typeface="Calibri" panose="020F0502020204030204" charset="0"/>
+                        </a:rPr>
+                        <a:t>Define the operating and cleaning sequence and update the records.</a:t>
                       </a:r>
                       <a:endParaRPr sz="1300" b="0">
                         <a:solidFill>
@@ -3947,7 +4126,9 @@
                     <a:bodyPr wrap="square"/>
                     <a:lstStyle/>
                     <a:p>
-                      <a:pPr algn="l"/>
+                      <a:pPr marL="342900" indent="-342900" algn="l">
+                        <a:buAutoNum type="arabicPeriod"/>
+                      </a:pPr>
                       <a:r>
                         <a:rPr sz="1300" b="0">
                           <a:solidFill>
@@ -3957,7 +4138,42 @@
                           <a:ea typeface="DejaVu Sans"/>
                           <a:cs typeface="Calibri" panose="020F0502020204030204" charset="0"/>
                         </a:rPr>
-                        <a:t>The design may be incomplete, and the CIP sequence and controls may be incomplete.</a:t>
+                        <a:t>The design may be incomplete, </a:t>
+                      </a:r>
+                      <a:endParaRPr sz="1300" b="0">
+                        <a:solidFill>
+                          <a:srgbClr val="1C2833"/>
+                        </a:solidFill>
+                        <a:latin typeface="Calibri" panose="020F0502020204030204" charset="0"/>
+                        <a:ea typeface="DejaVu Sans"/>
+                        <a:cs typeface="Calibri" panose="020F0502020204030204" charset="0"/>
+                      </a:endParaRPr>
+                    </a:p>
+                    <a:p>
+                      <a:pPr marL="342900" indent="-342900" algn="l">
+                        <a:buAutoNum type="arabicPeriod"/>
+                      </a:pPr>
+                      <a:r>
+                        <a:rPr lang="en-US" sz="1300" b="0">
+                          <a:solidFill>
+                            <a:srgbClr val="1C2833"/>
+                          </a:solidFill>
+                          <a:latin typeface="Calibri" panose="020F0502020204030204" charset="0"/>
+                          <a:ea typeface="DejaVu Sans"/>
+                          <a:cs typeface="Calibri" panose="020F0502020204030204" charset="0"/>
+                        </a:rPr>
+                        <a:t>T</a:t>
+                      </a:r>
+                      <a:r>
+                        <a:rPr sz="1300" b="0">
+                          <a:solidFill>
+                            <a:srgbClr val="1C2833"/>
+                          </a:solidFill>
+                          <a:latin typeface="Calibri" panose="020F0502020204030204" charset="0"/>
+                          <a:ea typeface="DejaVu Sans"/>
+                          <a:cs typeface="Calibri" panose="020F0502020204030204" charset="0"/>
+                        </a:rPr>
+                        <a:t>he CIP sequence and controls may be incomplete.</a:t>
                       </a:r>
                       <a:endParaRPr sz="1300" b="0">
                         <a:solidFill>
@@ -3980,7 +4196,9 @@
                     <a:bodyPr wrap="square"/>
                     <a:lstStyle/>
                     <a:p>
-                      <a:pPr algn="l"/>
+                      <a:pPr marL="342900" indent="-342900" algn="l">
+                        <a:buAutoNum type="arabicPeriod"/>
+                      </a:pPr>
                       <a:r>
                         <a:rPr sz="1300" b="0">
                           <a:solidFill>
@@ -3990,7 +4208,31 @@
                           <a:ea typeface="DejaVu Sans"/>
                           <a:cs typeface="Calibri" panose="020F0502020204030204" charset="0"/>
                         </a:rPr>
-                        <a:t>Qualify the system as a whole. Update the SOP and bring the requirements into routine use.</a:t>
+                        <a:t>Qualify the system as a whole. </a:t>
+                      </a:r>
+                      <a:endParaRPr sz="1300" b="0">
+                        <a:solidFill>
+                          <a:srgbClr val="1C2833"/>
+                        </a:solidFill>
+                        <a:latin typeface="Calibri" panose="020F0502020204030204" charset="0"/>
+                        <a:ea typeface="DejaVu Sans"/>
+                        <a:cs typeface="Calibri" panose="020F0502020204030204" charset="0"/>
+                      </a:endParaRPr>
+                    </a:p>
+                    <a:p>
+                      <a:pPr marL="342900" indent="-342900" algn="l">
+                        <a:buAutoNum type="arabicPeriod"/>
+                      </a:pPr>
+                      <a:r>
+                        <a:rPr sz="1300" b="0">
+                          <a:solidFill>
+                            <a:srgbClr val="1C2833"/>
+                          </a:solidFill>
+                          <a:latin typeface="Calibri" panose="020F0502020204030204" charset="0"/>
+                          <a:ea typeface="DejaVu Sans"/>
+                          <a:cs typeface="Calibri" panose="020F0502020204030204" charset="0"/>
+                        </a:rPr>
+                        <a:t>Update the SOP and bring the requirements into routine use.</a:t>
                       </a:r>
                       <a:endParaRPr sz="1300" b="0">
                         <a:solidFill>

</xml_diff>